<commit_message>
Update coaching report PPT
</commit_message>
<xml_diff>
--- a/02_COACHING_REPORT_NEVA_WILLIAMS.pptx
+++ b/02_COACHING_REPORT_NEVA_WILLIAMS.pptx
@@ -1229,9 +1229,8 @@
                 <a:ea typeface="Calibri" pitchFamily="34" charset="-122"/>
                 <a:cs typeface="Calibri" pitchFamily="34" charset="-120"/>
               </a:rPr>
-              <a:t>EPA measures how much each a play changed the chance of scoring, accounting for down, distance, field position, score, and the defense you're facing. The plays on the right show where that context changes everything, and where traditional metrics like yards and success rate stop telling the full story.</a:t>
-            </a:r>
-            <a:endParaRPr lang="en-US" sz="950" dirty="0"/>
+              <a:t>EPA captures how a play changes scoring value within its situation. The examples on the right show where context defines value, and where traditional metrics story telling the full story. EPA shows what the play was actually worth within its context, not just what it gained.</a:t>
+            </a:r>
           </a:p>
         </p:txBody>
       </p:sp>

</xml_diff>